<commit_message>
Schedule change: Days 1-3 Wed 14 to Fri 16 Oct, weekend rest, Days 4-7 Mon 19 to Thu 22 Oct; remove CIBN attribution
Co-Authored-By: Claude Sonnet 5.5 <noreply@anthropic.com>
</commit_message>
<xml_diff>
--- a/decks/MIPF_Day3_Finance_Fundamentals_Deck.pptx
+++ b/decks/MIPF_Day3_Finance_Fundamentals_Deck.pptx
@@ -34016,7 +34016,7 @@
                 </a:solidFill>
                 <a:latin typeface="Calibri"/>
               </a:rPr>
-              <a:t>A tour before we build, so Saturday morning feels familiar.</a:t>
+              <a:t>A tour before we build, so Monday morning feels familiar.</a:t>
             </a:r>
           </a:p>
         </p:txBody>
@@ -35778,7 +35778,7 @@
                 </a:solidFill>
                 <a:latin typeface="Georgia"/>
               </a:rPr>
-              <a:t>Set-up check for Saturday (Day 4)</a:t>
+              <a:t>Set-up check for Monday (Day 4)</a:t>
             </a:r>
           </a:p>
         </p:txBody>
@@ -36273,7 +36273,7 @@
                 </a:solidFill>
                 <a:latin typeface="Calibri"/>
               </a:rPr>
-              <a:t>Day 4 is Saturday 17 October; Sunday 18 is a rest day; Day 5 is Monday 19 October.</a:t>
+              <a:t>Days 1 to 3 end today. Saturday 17 and Sunday 18 October are rest days; Day 4 is Monday 19 October and Day 5 is Tuesday 20 October.</a:t>
             </a:r>
           </a:p>
         </p:txBody>
@@ -36815,7 +36815,7 @@
                 </a:solidFill>
                 <a:latin typeface="Calibri"/>
               </a:rPr>
-              <a:t>Next: Day 4 (Saturday): build the operating model: Time, Esc, Revenue, Operating cost and Tax.</a:t>
+              <a:t>Next: Day 4 (Monday 19 October): build the operating model: Time, Esc, Revenue, Operating cost and Tax.</a:t>
             </a:r>
           </a:p>
         </p:txBody>

</xml_diff>